<commit_message>
deck 3-2 author review Band P0: s17 optimizer convergence + spill, s26 clipped row, s27 method-flowchart arrow direction and Accept/reject vs Alignment
</commit_message>
<xml_diff>
--- a/course/lectures/act-3-software-in-the-world/03-data-management/3-2-Data-Management.pptx
+++ b/course/lectures/act-3-software-in-the-world/03-data-management/3-2-Data-Management.pptx
@@ -2260,6 +2260,12 @@
               <a:t>PLACEMENT NOTE, deliberate and worth saying: query optimization belongs HERE, under execution — it is about running ONE query efficiently. Transactions (§5) are about which CONCURRENT HISTORIES are permitted. They interact (locking can change plan costs) but they solve different problems. Filing optimization under transactions is a category error.</a:t>
             </a:r>
           </a:p>
+          <a:p/>
+          <a:p>
+            <a:r>
+              <a:t>Moved from slide (bottom panel): It compares candidate plans by estimated cost, using statistics about YOUR data — Same SQL, thousandfold cost differences. The levers you supply: indexes, layout, fresh statistics. The optimizer compares candidate plans by estimated cost, using statistics about YOUR data; same SQL can differ in cost a thousandfold, and the levers you supply are indexes, layout, and fresh statistics.</a:t>
+            </a:r>
+          </a:p>
         </p:txBody>
       </p:sp>
       <p:sp>
@@ -3291,6 +3297,12 @@
               <a:t>Rollback question for the class: code rolls back by redeploying the old image — what rolls back a migration that already rewrote rows?</a:t>
             </a:r>
           </a:p>
+          <a:p/>
+          <a:p>
+            <a:r>
+              <a:t>Moved from slide (availability row detail): Can the old version keep operating mid-migration? Expand → migrate → contract: add the new shape alongside the old, migrate readers and writers, then retire the old shape once nothing depends on it.</a:t>
+            </a:r>
+          </a:p>
         </p:txBody>
       </p:sp>
       <p:sp>
@@ -3381,6 +3393,12 @@
           <a:p>
             <a:r>
               <a:t>(Deck-maintenance note, not for class: Tuesday's deck renders this same chart; the two renderings should be reconciled to one geometry after both decks land.)</a:t>
+            </a:r>
+          </a:p>
+          <a:p/>
+          <a:p>
+            <a:r>
+              <a:t>Revised framing (author review): Accept/reject asks whether the realized implementation satisfies its obligation — no overlapping confirmed reservations — as shown by the evidence. Adopting the exclusion constraint is NOT the acceptance decision; it is the Alignment mechanism: the schema rejects invalid writes independently of any application code path. The lower row runs leftward: Realize, then Evidence, then Accept/reject — same direction and semantics as the Act III kickoff deck's method flowchart.</a:t>
             </a:r>
           </a:p>
         </p:txBody>
@@ -15914,7 +15932,7 @@
       </p:sp>
       <p:sp>
         <p:nvSpPr>
-          <p:cNvPr id="20" name="Block" descr="Query execution diagram: parse and validate feeds a logical plan; the logical plan and statistics about your data feed the optimizer; two candidate plans branch from it, sequential scan and index range scan; the lowest estimated cost executes"/>
+          <p:cNvPr id="20" name="Block" descr="Query execution diagram: parse and validate feeds a logical plan; the logical plan and statistics about your data feed the optimizer; the optimizer forks to two candidate plans, sequential scan and index range scan; both candidates converge on a cost comparison, the lowest estimated cost wins, and the chosen plan is executed"/>
           <p:cNvSpPr/>
           <p:nvPr/>
         </p:nvSpPr>
@@ -16062,78 +16080,6 @@
           </a:p>
         </p:txBody>
       </p:sp>
-      <p:cxnSp>
-        <p:nvCxnSpPr>
-          <p:cNvPr id="23" name="PlanBranch"/>
-          <p:cNvCxnSpPr/>
-          <p:nvPr/>
-        </p:nvCxnSpPr>
-        <p:spPr>
-          <a:xfrm flipH="1">
-            <a:off x="2377440" y="2633472"/>
-            <a:ext cx="822960" cy="338328"/>
-          </a:xfrm>
-          <a:prstGeom prst="line">
-            <a:avLst/>
-          </a:prstGeom>
-          <a:ln w="31750">
-            <a:solidFill>
-              <a:srgbClr val="8E6F3E"/>
-            </a:solidFill>
-            <a:tailEnd type="triangle" w="med" len="med"/>
-          </a:ln>
-        </p:spPr>
-        <p:style>
-          <a:lnRef idx="2">
-            <a:schemeClr val="accent1"/>
-          </a:lnRef>
-          <a:fillRef idx="0">
-            <a:schemeClr val="accent1"/>
-          </a:fillRef>
-          <a:effectRef idx="1">
-            <a:schemeClr val="accent1"/>
-          </a:effectRef>
-          <a:fontRef idx="minor">
-            <a:schemeClr val="tx1"/>
-          </a:fontRef>
-        </p:style>
-      </p:cxnSp>
-      <p:cxnSp>
-        <p:nvCxnSpPr>
-          <p:cNvPr id="24" name="PlanBranch"/>
-          <p:cNvCxnSpPr/>
-          <p:nvPr/>
-        </p:nvCxnSpPr>
-        <p:spPr>
-          <a:xfrm>
-            <a:off x="4114800" y="2633472"/>
-            <a:ext cx="2468880" cy="338328"/>
-          </a:xfrm>
-          <a:prstGeom prst="line">
-            <a:avLst/>
-          </a:prstGeom>
-          <a:ln w="31750">
-            <a:solidFill>
-              <a:srgbClr val="8E6F3E"/>
-            </a:solidFill>
-            <a:tailEnd type="triangle" w="med" len="med"/>
-          </a:ln>
-        </p:spPr>
-        <p:style>
-          <a:lnRef idx="2">
-            <a:schemeClr val="accent1"/>
-          </a:lnRef>
-          <a:fillRef idx="0">
-            <a:schemeClr val="accent1"/>
-          </a:fillRef>
-          <a:effectRef idx="1">
-            <a:schemeClr val="accent1"/>
-          </a:effectRef>
-          <a:fontRef idx="minor">
-            <a:schemeClr val="tx1"/>
-          </a:fontRef>
-        </p:style>
-      </p:cxnSp>
       <p:sp>
         <p:nvSpPr>
           <p:cNvPr id="25" name="Candidate"/>
@@ -16142,7 +16088,7 @@
         </p:nvSpPr>
         <p:spPr>
           <a:xfrm>
-            <a:off x="640080" y="2971800"/>
+            <a:off x="640080" y="3063240"/>
             <a:ext cx="3474720" cy="868680"/>
           </a:xfrm>
           <a:prstGeom prst="rect">
@@ -16188,7 +16134,7 @@
         </p:nvSpPr>
         <p:spPr>
           <a:xfrm>
-            <a:off x="768096" y="3026664"/>
+            <a:off x="768096" y="3118104"/>
             <a:ext cx="3218688" cy="777240"/>
           </a:xfrm>
           <a:prstGeom prst="rect">
@@ -16233,7 +16179,7 @@
         </p:nvSpPr>
         <p:spPr>
           <a:xfrm>
-            <a:off x="4846320" y="2971800"/>
+            <a:off x="4846320" y="3063240"/>
             <a:ext cx="3474720" cy="868680"/>
           </a:xfrm>
           <a:prstGeom prst="rect">
@@ -16279,7 +16225,7 @@
         </p:nvSpPr>
         <p:spPr>
           <a:xfrm>
-            <a:off x="4974336" y="3026664"/>
+            <a:off x="4974336" y="3118104"/>
             <a:ext cx="3218688" cy="777240"/>
           </a:xfrm>
           <a:prstGeom prst="rect">
@@ -16316,16 +16262,86 @@
           </a:p>
         </p:txBody>
       </p:sp>
-      <p:sp>
-        <p:nvSpPr>
-          <p:cNvPr id="29" name="Arrow"/>
+      <p:cxnSp>
+        <p:nvCxnSpPr>
+          <p:cNvPr id="29" name="ForkTrunk"/>
+          <p:cNvCxnSpPr/>
+          <p:nvPr/>
+        </p:nvCxnSpPr>
+        <p:spPr>
+          <a:xfrm>
+            <a:off x="3657600" y="2606040"/>
+            <a:ext cx="0" cy="228600"/>
+          </a:xfrm>
+          <a:prstGeom prst="line">
+            <a:avLst/>
+          </a:prstGeom>
+          <a:ln w="25400">
+            <a:solidFill>
+              <a:srgbClr val="8E6F3E"/>
+            </a:solidFill>
+          </a:ln>
+        </p:spPr>
+        <p:style>
+          <a:lnRef idx="2">
+            <a:schemeClr val="accent1"/>
+          </a:lnRef>
+          <a:fillRef idx="0">
+            <a:schemeClr val="accent1"/>
+          </a:fillRef>
+          <a:effectRef idx="1">
+            <a:schemeClr val="accent1"/>
+          </a:effectRef>
+          <a:fontRef idx="minor">
+            <a:schemeClr val="tx1"/>
+          </a:fontRef>
+        </p:style>
+      </p:cxnSp>
+      <p:cxnSp>
+        <p:nvCxnSpPr>
+          <p:cNvPr id="30" name="ForkRail"/>
+          <p:cNvCxnSpPr/>
+          <p:nvPr/>
+        </p:nvCxnSpPr>
+        <p:spPr>
+          <a:xfrm>
+            <a:off x="2377440" y="2834640"/>
+            <a:ext cx="4206240" cy="0"/>
+          </a:xfrm>
+          <a:prstGeom prst="line">
+            <a:avLst/>
+          </a:prstGeom>
+          <a:ln w="25400">
+            <a:solidFill>
+              <a:srgbClr val="8E6F3E"/>
+            </a:solidFill>
+          </a:ln>
+        </p:spPr>
+        <p:style>
+          <a:lnRef idx="2">
+            <a:schemeClr val="accent1"/>
+          </a:lnRef>
+          <a:fillRef idx="0">
+            <a:schemeClr val="accent1"/>
+          </a:fillRef>
+          <a:effectRef idx="1">
+            <a:schemeClr val="accent1"/>
+          </a:effectRef>
+          <a:fontRef idx="minor">
+            <a:schemeClr val="tx1"/>
+          </a:fontRef>
+        </p:style>
+      </p:cxnSp>
+      <p:sp>
+        <p:nvSpPr>
+          <p:cNvPr id="31" name="Arrow"/>
           <p:cNvSpPr/>
           <p:nvPr/>
         </p:nvSpPr>
         <p:spPr>
           <a:xfrm>
-            <a:off x="6446520" y="3877056"/>
-            <a:ext cx="274320" cy="274320"/>
+            <a:off x="2240280" y="2834640"/>
+            <a:ext cx="274320" cy="228600"/>
           </a:xfrm>
           <a:prstGeom prst="downArrow">
             <a:avLst/>
@@ -16353,7 +16369,7 @@
           </a:fontRef>
         </p:style>
         <p:txBody>
-          <a:bodyPr rtlCol="0" anchor="ctr"/>
+          <a:bodyPr rtlCol="0" anchor="ctr" wrap="square"/>
           <a:lstStyle/>
           <a:p>
             <a:pPr algn="ctr"/>
@@ -16362,51 +16378,16 @@
       </p:sp>
       <p:sp>
         <p:nvSpPr>
-          <p:cNvPr id="30" name="ChoiceLabel"/>
-          <p:cNvSpPr txBox="1"/>
-          <p:nvPr/>
-        </p:nvSpPr>
-        <p:spPr>
-          <a:xfrm>
-            <a:off x="640080" y="4224528"/>
-            <a:ext cx="4023360" cy="347472"/>
-          </a:xfrm>
-          <a:prstGeom prst="rect">
-            <a:avLst/>
-          </a:prstGeom>
-          <a:noFill/>
-        </p:spPr>
-        <p:txBody>
-          <a:bodyPr wrap="square">
-            <a:spAutoFit/>
-          </a:bodyPr>
-          <a:lstStyle/>
-          <a:p>
-            <a:pPr algn="r"/>
-            <a:r>
-              <a:rPr sz="2000" b="0">
-                <a:solidFill>
-                  <a:srgbClr val="555960"/>
-                </a:solidFill>
-                <a:latin typeface="Calibri"/>
-              </a:rPr>
-              <a:t>lowest estimated cost wins</a:t>
-            </a:r>
-          </a:p>
-        </p:txBody>
-      </p:sp>
-      <p:sp>
-        <p:nvSpPr>
-          <p:cNvPr id="31" name="Block"/>
+          <p:cNvPr id="32" name="Arrow"/>
           <p:cNvSpPr/>
           <p:nvPr/>
         </p:nvSpPr>
         <p:spPr>
           <a:xfrm>
-            <a:off x="4846320" y="4187952"/>
-            <a:ext cx="3474720" cy="548640"/>
-          </a:xfrm>
-          <a:prstGeom prst="rect">
+            <a:off x="6446520" y="2834640"/>
+            <a:ext cx="274320" cy="228600"/>
+          </a:xfrm>
+          <a:prstGeom prst="downArrow">
             <a:avLst/>
           </a:prstGeom>
           <a:solidFill>
@@ -16436,34 +16417,130 @@
           <a:lstStyle/>
           <a:p>
             <a:pPr algn="ctr"/>
-            <a:r>
-              <a:rPr sz="2000" b="1">
-                <a:solidFill>
-                  <a:srgbClr val="FFFFFF"/>
-                </a:solidFill>
-                <a:latin typeface="Calibri"/>
-              </a:rPr>
-              <a:t>Execute the chosen plan</a:t>
-            </a:r>
-          </a:p>
-        </p:txBody>
-      </p:sp>
-      <p:sp>
-        <p:nvSpPr>
-          <p:cNvPr id="14" name="Card"/>
+          </a:p>
+        </p:txBody>
+      </p:sp>
+      <p:cxnSp>
+        <p:nvCxnSpPr>
+          <p:cNvPr id="33" name="MergeDrop"/>
+          <p:cNvCxnSpPr/>
+          <p:nvPr/>
+        </p:nvCxnSpPr>
+        <p:spPr>
+          <a:xfrm>
+            <a:off x="2377440" y="3931920"/>
+            <a:ext cx="0" cy="274320"/>
+          </a:xfrm>
+          <a:prstGeom prst="line">
+            <a:avLst/>
+          </a:prstGeom>
+          <a:ln w="25400">
+            <a:solidFill>
+              <a:srgbClr val="8E6F3E"/>
+            </a:solidFill>
+          </a:ln>
+        </p:spPr>
+        <p:style>
+          <a:lnRef idx="2">
+            <a:schemeClr val="accent1"/>
+          </a:lnRef>
+          <a:fillRef idx="0">
+            <a:schemeClr val="accent1"/>
+          </a:fillRef>
+          <a:effectRef idx="1">
+            <a:schemeClr val="accent1"/>
+          </a:effectRef>
+          <a:fontRef idx="minor">
+            <a:schemeClr val="tx1"/>
+          </a:fontRef>
+        </p:style>
+      </p:cxnSp>
+      <p:cxnSp>
+        <p:nvCxnSpPr>
+          <p:cNvPr id="34" name="MergeDrop"/>
+          <p:cNvCxnSpPr/>
+          <p:nvPr/>
+        </p:nvCxnSpPr>
+        <p:spPr>
+          <a:xfrm>
+            <a:off x="6583680" y="3931920"/>
+            <a:ext cx="0" cy="274320"/>
+          </a:xfrm>
+          <a:prstGeom prst="line">
+            <a:avLst/>
+          </a:prstGeom>
+          <a:ln w="25400">
+            <a:solidFill>
+              <a:srgbClr val="8E6F3E"/>
+            </a:solidFill>
+          </a:ln>
+        </p:spPr>
+        <p:style>
+          <a:lnRef idx="2">
+            <a:schemeClr val="accent1"/>
+          </a:lnRef>
+          <a:fillRef idx="0">
+            <a:schemeClr val="accent1"/>
+          </a:fillRef>
+          <a:effectRef idx="1">
+            <a:schemeClr val="accent1"/>
+          </a:effectRef>
+          <a:fontRef idx="minor">
+            <a:schemeClr val="tx1"/>
+          </a:fontRef>
+        </p:style>
+      </p:cxnSp>
+      <p:cxnSp>
+        <p:nvCxnSpPr>
+          <p:cNvPr id="35" name="MergeRail"/>
+          <p:cNvCxnSpPr/>
+          <p:nvPr/>
+        </p:nvCxnSpPr>
+        <p:spPr>
+          <a:xfrm>
+            <a:off x="2377440" y="4206240"/>
+            <a:ext cx="4206240" cy="0"/>
+          </a:xfrm>
+          <a:prstGeom prst="line">
+            <a:avLst/>
+          </a:prstGeom>
+          <a:ln w="25400">
+            <a:solidFill>
+              <a:srgbClr val="8E6F3E"/>
+            </a:solidFill>
+          </a:ln>
+        </p:spPr>
+        <p:style>
+          <a:lnRef idx="2">
+            <a:schemeClr val="accent1"/>
+          </a:lnRef>
+          <a:fillRef idx="0">
+            <a:schemeClr val="accent1"/>
+          </a:fillRef>
+          <a:effectRef idx="1">
+            <a:schemeClr val="accent1"/>
+          </a:effectRef>
+          <a:fontRef idx="minor">
+            <a:schemeClr val="tx1"/>
+          </a:fontRef>
+        </p:style>
+      </p:cxnSp>
+      <p:sp>
+        <p:nvSpPr>
+          <p:cNvPr id="36" name="Arrow"/>
           <p:cNvSpPr/>
           <p:nvPr/>
         </p:nvSpPr>
         <p:spPr>
           <a:xfrm>
-            <a:off x="411480" y="4892040"/>
-            <a:ext cx="8321040" cy="960120"/>
-          </a:xfrm>
-          <a:prstGeom prst="rect">
+            <a:off x="4343400" y="4206240"/>
+            <a:ext cx="274320" cy="228600"/>
+          </a:xfrm>
+          <a:prstGeom prst="downArrow">
             <a:avLst/>
           </a:prstGeom>
           <a:solidFill>
-            <a:srgbClr val="F5F1E8"/>
+            <a:srgbClr val="8E6F3E"/>
           </a:solidFill>
           <a:ln>
             <a:noFill/>
@@ -16494,55 +16571,174 @@
       </p:sp>
       <p:sp>
         <p:nvSpPr>
-          <p:cNvPr id="15" name="CardBody"/>
-          <p:cNvSpPr txBox="1"/>
-          <p:nvPr/>
-        </p:nvSpPr>
-        <p:spPr>
-          <a:xfrm>
-            <a:off x="557784" y="4965192"/>
-            <a:ext cx="8046720" cy="822960"/>
-          </a:xfrm>
-          <a:prstGeom prst="rect">
-            <a:avLst/>
-          </a:prstGeom>
-          <a:noFill/>
-        </p:spPr>
-        <p:txBody>
-          <a:bodyPr wrap="square">
-            <a:spAutoFit/>
-          </a:bodyPr>
-          <a:lstStyle/>
-          <a:p>
-            <a:pPr algn="l">
-              <a:spcAft>
-                <a:spcPts val="300"/>
+          <p:cNvPr id="37" name="Block"/>
+          <p:cNvSpPr/>
+          <p:nvPr/>
+        </p:nvSpPr>
+        <p:spPr>
+          <a:xfrm>
+            <a:off x="2834640" y="4434840"/>
+            <a:ext cx="3291840" cy="731520"/>
+          </a:xfrm>
+          <a:prstGeom prst="rect">
+            <a:avLst/>
+          </a:prstGeom>
+          <a:solidFill>
+            <a:srgbClr val="8E6F3E"/>
+          </a:solidFill>
+          <a:ln>
+            <a:noFill/>
+          </a:ln>
+          <a:effectLst/>
+        </p:spPr>
+        <p:style>
+          <a:lnRef idx="1">
+            <a:schemeClr val="accent1"/>
+          </a:lnRef>
+          <a:fillRef idx="3">
+            <a:schemeClr val="accent1"/>
+          </a:fillRef>
+          <a:effectRef idx="2">
+            <a:schemeClr val="accent1"/>
+          </a:effectRef>
+          <a:fontRef idx="minor">
+            <a:schemeClr val="lt1"/>
+          </a:fontRef>
+        </p:style>
+        <p:txBody>
+          <a:bodyPr rtlCol="0" anchor="ctr" wrap="square"/>
+          <a:lstStyle/>
+          <a:p>
+            <a:pPr algn="ctr">
+              <a:spcAft>
+                <a:spcPts val="0"/>
               </a:spcAft>
             </a:pPr>
             <a:r>
               <a:rPr sz="2000" b="1">
                 <a:solidFill>
-                  <a:srgbClr val="5C4826"/>
-                </a:solidFill>
-                <a:latin typeface="Calibri"/>
-              </a:rPr>
-              <a:t>It compares candidate plans by estimated cost, using statistics about YOUR data</a:t>
-            </a:r>
-          </a:p>
-          <a:p>
-            <a:pPr algn="l">
-              <a:spcAft>
-                <a:spcPts val="400"/>
+                  <a:srgbClr val="FFFFFF"/>
+                </a:solidFill>
+                <a:latin typeface="Calibri"/>
+              </a:rPr>
+              <a:t>COST COMPARISON</a:t>
+            </a:r>
+          </a:p>
+          <a:p>
+            <a:pPr algn="ctr">
+              <a:spcAft>
+                <a:spcPts val="0"/>
               </a:spcAft>
             </a:pPr>
             <a:r>
               <a:rPr sz="2000" b="0">
                 <a:solidFill>
-                  <a:srgbClr val="555960"/>
-                </a:solidFill>
-                <a:latin typeface="Calibri"/>
-              </a:rPr>
-              <a:t>Same SQL, thousandfold cost differences. The levers you supply: indexes, layout, fresh statistics.</a:t>
+                  <a:srgbClr val="FFFFFF"/>
+                </a:solidFill>
+                <a:latin typeface="Calibri"/>
+              </a:rPr>
+              <a:t>lowest estimated cost wins</a:t>
+            </a:r>
+          </a:p>
+        </p:txBody>
+      </p:sp>
+      <p:sp>
+        <p:nvSpPr>
+          <p:cNvPr id="38" name="Arrow"/>
+          <p:cNvSpPr/>
+          <p:nvPr/>
+        </p:nvSpPr>
+        <p:spPr>
+          <a:xfrm>
+            <a:off x="4343400" y="5166360"/>
+            <a:ext cx="274320" cy="228600"/>
+          </a:xfrm>
+          <a:prstGeom prst="downArrow">
+            <a:avLst/>
+          </a:prstGeom>
+          <a:solidFill>
+            <a:srgbClr val="8E6F3E"/>
+          </a:solidFill>
+          <a:ln>
+            <a:noFill/>
+          </a:ln>
+          <a:effectLst/>
+        </p:spPr>
+        <p:style>
+          <a:lnRef idx="1">
+            <a:schemeClr val="accent1"/>
+          </a:lnRef>
+          <a:fillRef idx="3">
+            <a:schemeClr val="accent1"/>
+          </a:fillRef>
+          <a:effectRef idx="2">
+            <a:schemeClr val="accent1"/>
+          </a:effectRef>
+          <a:fontRef idx="minor">
+            <a:schemeClr val="lt1"/>
+          </a:fontRef>
+        </p:style>
+        <p:txBody>
+          <a:bodyPr rtlCol="0" anchor="ctr" wrap="square"/>
+          <a:lstStyle/>
+          <a:p>
+            <a:pPr algn="ctr"/>
+          </a:p>
+        </p:txBody>
+      </p:sp>
+      <p:sp>
+        <p:nvSpPr>
+          <p:cNvPr id="39" name="Block"/>
+          <p:cNvSpPr/>
+          <p:nvPr/>
+        </p:nvSpPr>
+        <p:spPr>
+          <a:xfrm>
+            <a:off x="2834640" y="5394960"/>
+            <a:ext cx="3291840" cy="548640"/>
+          </a:xfrm>
+          <a:prstGeom prst="rect">
+            <a:avLst/>
+          </a:prstGeom>
+          <a:solidFill>
+            <a:srgbClr val="8E6F3E"/>
+          </a:solidFill>
+          <a:ln>
+            <a:noFill/>
+          </a:ln>
+          <a:effectLst/>
+        </p:spPr>
+        <p:style>
+          <a:lnRef idx="1">
+            <a:schemeClr val="accent1"/>
+          </a:lnRef>
+          <a:fillRef idx="3">
+            <a:schemeClr val="accent1"/>
+          </a:fillRef>
+          <a:effectRef idx="2">
+            <a:schemeClr val="accent1"/>
+          </a:effectRef>
+          <a:fontRef idx="minor">
+            <a:schemeClr val="lt1"/>
+          </a:fontRef>
+        </p:style>
+        <p:txBody>
+          <a:bodyPr rtlCol="0" anchor="ctr" wrap="square"/>
+          <a:lstStyle/>
+          <a:p>
+            <a:pPr algn="ctr">
+              <a:spcAft>
+                <a:spcPts val="0"/>
+              </a:spcAft>
+            </a:pPr>
+            <a:r>
+              <a:rPr sz="2000" b="1">
+                <a:solidFill>
+                  <a:srgbClr val="FFFFFF"/>
+                </a:solidFill>
+                <a:latin typeface="Calibri"/>
+              </a:rPr>
+              <a:t>Execute the chosen plan</a:t>
             </a:r>
           </a:p>
         </p:txBody>
@@ -22249,7 +22445,7 @@
                 </a:solidFill>
                 <a:latin typeface="Calibri"/>
               </a:rPr>
-              <a:t>AVAILABILITY DURING CHANGE</a:t>
+              <a:t>AVAILABILITY DURING MIGRATION</a:t>
             </a:r>
           </a:p>
         </p:txBody>
@@ -22288,7 +22484,7 @@
                 </a:solidFill>
                 <a:latin typeface="Calibri"/>
               </a:rPr>
-              <a:t>Can the old version keep operating mid-migration?</a:t>
+              <a:t>Can old and new versions operate simultaneously?</a:t>
             </a:r>
           </a:p>
           <a:p>
@@ -22304,7 +22500,7 @@
                 </a:solidFill>
                 <a:latin typeface="Calibri"/>
               </a:rPr>
-              <a:t>Expand → migrate → contract: add the new shape, move, then retire the old</a:t>
+              <a:t>Expand → Migrate → Contract</a:t>
             </a:r>
           </a:p>
         </p:txBody>
@@ -22372,13 +22568,13 @@
       </p:sp>
       <p:sp>
         <p:nvSpPr>
-          <p:cNvPr id="3" name="Block" descr="Act III engineering method flowchart populated with this lecture's decisions: problem (preserve correct reservations), model (entities, intervals, invariant), judgment (relational, normalized), realize (schema and queries), evidence (plans and the race), accept or reject (adopt the exclusion constraint); an alignment lane runs alongside"/>
+          <p:cNvPr id="3" name="Block" descr="Act III engineering method flowchart populated with this lecture's decisions: problem (preserve correct reservations) leads to model (entities, intervals, invariant) leads to judgment (relational storage, enforcement strategy); judgment leads down to realize (schema, queries, transactions), which leads left to evidence (concurrency tests, query plans), which leads left to accept or reject (no overlapping confirmed reservations); an alignment mechanism, the exclusion constraint rejecting invalid writes independent of application code, governs realization"/>
           <p:cNvSpPr/>
           <p:nvPr/>
         </p:nvSpPr>
         <p:spPr>
           <a:xfrm>
-            <a:off x="411480" y="914400"/>
+            <a:off x="411480" y="1371600"/>
             <a:ext cx="2468880" cy="1188720"/>
           </a:xfrm>
           <a:prstGeom prst="rect">
@@ -22447,7 +22643,7 @@
         </p:nvSpPr>
         <p:spPr>
           <a:xfrm>
-            <a:off x="3337560" y="914400"/>
+            <a:off x="3337560" y="1371600"/>
             <a:ext cx="2468880" cy="1188720"/>
           </a:xfrm>
           <a:prstGeom prst="rect">
@@ -22516,7 +22712,7 @@
         </p:nvSpPr>
         <p:spPr>
           <a:xfrm>
-            <a:off x="6263640" y="914400"/>
+            <a:off x="6263640" y="1371600"/>
             <a:ext cx="2468880" cy="1188720"/>
           </a:xfrm>
           <a:prstGeom prst="rect">
@@ -22572,7 +22768,7 @@
                 </a:solidFill>
                 <a:latin typeface="Calibri"/>
               </a:rPr>
-              <a:t>relational, normalized</a:t>
+              <a:t>relational storage, enforcement strategy</a:t>
             </a:r>
           </a:p>
         </p:txBody>
@@ -22585,7 +22781,7 @@
         </p:nvSpPr>
         <p:spPr>
           <a:xfrm>
-            <a:off x="2907792" y="1408176"/>
+            <a:off x="2907792" y="1865376"/>
             <a:ext cx="402336" cy="201168"/>
           </a:xfrm>
           <a:prstGeom prst="rightArrow">
@@ -22629,7 +22825,7 @@
         </p:nvSpPr>
         <p:spPr>
           <a:xfrm>
-            <a:off x="5833872" y="1408176"/>
+            <a:off x="5833872" y="1865376"/>
             <a:ext cx="402336" cy="201168"/>
           </a:xfrm>
           <a:prstGeom prst="rightArrow">
@@ -22673,7 +22869,7 @@
         </p:nvSpPr>
         <p:spPr>
           <a:xfrm>
-            <a:off x="7315200" y="2121408"/>
+            <a:off x="7315200" y="2578608"/>
             <a:ext cx="365760" cy="420624"/>
           </a:xfrm>
           <a:prstGeom prst="downArrow">
@@ -22717,7 +22913,7 @@
         </p:nvSpPr>
         <p:spPr>
           <a:xfrm>
-            <a:off x="6263640" y="2560320"/>
+            <a:off x="6263640" y="3017520"/>
             <a:ext cx="2468880" cy="1188720"/>
           </a:xfrm>
           <a:prstGeom prst="rect">
@@ -22773,7 +22969,7 @@
                 </a:solidFill>
                 <a:latin typeface="Calibri"/>
               </a:rPr>
-              <a:t>schema and queries</a:t>
+              <a:t>schema, queries, transactions</a:t>
             </a:r>
           </a:p>
         </p:txBody>
@@ -22786,7 +22982,7 @@
         </p:nvSpPr>
         <p:spPr>
           <a:xfrm>
-            <a:off x="3337560" y="2560320"/>
+            <a:off x="3337560" y="3017520"/>
             <a:ext cx="2468880" cy="1188720"/>
           </a:xfrm>
           <a:prstGeom prst="rect">
@@ -22842,7 +23038,7 @@
                 </a:solidFill>
                 <a:latin typeface="Calibri"/>
               </a:rPr>
-              <a:t>plans and the race</a:t>
+              <a:t>concurrency tests, query plans</a:t>
             </a:r>
           </a:p>
         </p:txBody>
@@ -22855,7 +23051,7 @@
         </p:nvSpPr>
         <p:spPr>
           <a:xfrm>
-            <a:off x="411480" y="2560320"/>
+            <a:off x="411480" y="3017520"/>
             <a:ext cx="2468880" cy="1188720"/>
           </a:xfrm>
           <a:prstGeom prst="rect">
@@ -22911,7 +23107,7 @@
                 </a:solidFill>
                 <a:latin typeface="Calibri"/>
               </a:rPr>
-              <a:t>adopt the exclusion constraint</a:t>
+              <a:t>no overlapping confirmed reservations</a:t>
             </a:r>
           </a:p>
         </p:txBody>
@@ -22923,8 +23119,8 @@
           <p:nvPr/>
         </p:nvSpPr>
         <p:spPr>
-          <a:xfrm flipH="1">
-            <a:off x="5833872" y="3054096"/>
+          <a:xfrm>
+            <a:off x="5833872" y="3511296"/>
             <a:ext cx="402336" cy="201168"/>
           </a:xfrm>
           <a:prstGeom prst="leftArrow">
@@ -22967,8 +23163,8 @@
           <p:nvPr/>
         </p:nvSpPr>
         <p:spPr>
-          <a:xfrm flipH="1">
-            <a:off x="2907792" y="3054096"/>
+          <a:xfrm>
+            <a:off x="2907792" y="3511296"/>
             <a:ext cx="402336" cy="201168"/>
           </a:xfrm>
           <a:prstGeom prst="leftArrow">
@@ -23012,8 +23208,8 @@
         </p:nvSpPr>
         <p:spPr>
           <a:xfrm>
-            <a:off x="411480" y="4041648"/>
-            <a:ext cx="8321040" cy="566928"/>
+            <a:off x="411480" y="4498848"/>
+            <a:ext cx="8321040" cy="777240"/>
           </a:xfrm>
           <a:prstGeom prst="rect">
             <a:avLst/>
@@ -23056,20 +23252,20 @@
                 </a:solidFill>
                 <a:latin typeface="Calibri"/>
               </a:rPr>
-              <a:t>ALIGNMENT, alongside every step: schema constraints, checks, gates</a:t>
+              <a:t>ALIGNMENT: the exclusion constraint rejects invalid writes, independent of application code</a:t>
             </a:r>
           </a:p>
         </p:txBody>
       </p:sp>
       <p:cxnSp>
         <p:nvCxnSpPr>
-          <p:cNvPr id="15" name="AlignLink"/>
+          <p:cNvPr id="16" name="AlignLink"/>
           <p:cNvCxnSpPr/>
           <p:nvPr/>
         </p:nvCxnSpPr>
         <p:spPr>
           <a:xfrm>
-            <a:off x="1645920" y="3749039"/>
+            <a:off x="7498079" y="4206239"/>
             <a:ext cx="0" cy="292608"/>
           </a:xfrm>
           <a:prstGeom prst="line">
@@ -23096,158 +23292,6 @@
           </a:fontRef>
         </p:style>
       </p:cxnSp>
-      <p:cxnSp>
-        <p:nvCxnSpPr>
-          <p:cNvPr id="16" name="AlignLink"/>
-          <p:cNvCxnSpPr/>
-          <p:nvPr/>
-        </p:nvCxnSpPr>
-        <p:spPr>
-          <a:xfrm>
-            <a:off x="7498079" y="3749039"/>
-            <a:ext cx="0" cy="292608"/>
-          </a:xfrm>
-          <a:prstGeom prst="line">
-            <a:avLst/>
-          </a:prstGeom>
-          <a:ln w="25400">
-            <a:solidFill>
-              <a:srgbClr val="8E6F3E"/>
-            </a:solidFill>
-          </a:ln>
-        </p:spPr>
-        <p:style>
-          <a:lnRef idx="2">
-            <a:schemeClr val="accent1"/>
-          </a:lnRef>
-          <a:fillRef idx="0">
-            <a:schemeClr val="accent1"/>
-          </a:fillRef>
-          <a:effectRef idx="1">
-            <a:schemeClr val="accent1"/>
-          </a:effectRef>
-          <a:fontRef idx="minor">
-            <a:schemeClr val="tx1"/>
-          </a:fontRef>
-        </p:style>
-      </p:cxnSp>
-      <p:sp>
-        <p:nvSpPr>
-          <p:cNvPr id="21" name="MethodNote"/>
-          <p:cNvSpPr txBox="1"/>
-          <p:nvPr/>
-        </p:nvSpPr>
-        <p:spPr>
-          <a:xfrm>
-            <a:off x="411480" y="4937760"/>
-            <a:ext cx="8321040" cy="731520"/>
-          </a:xfrm>
-          <a:prstGeom prst="rect">
-            <a:avLst/>
-          </a:prstGeom>
-          <a:noFill/>
-        </p:spPr>
-        <p:txBody>
-          <a:bodyPr wrap="square">
-            <a:spAutoFit/>
-          </a:bodyPr>
-          <a:lstStyle/>
-          <a:p>
-            <a:r>
-              <a:rPr sz="2000" b="0">
-                <a:solidFill>
-                  <a:srgbClr val="555960"/>
-                </a:solidFill>
-                <a:latin typeface="Calibri"/>
-              </a:rPr>
-              <a:t>Tuesday's frame, today's artifacts: every box filled by a decision made in this lecture.</a:t>
-            </a:r>
-          </a:p>
-        </p:txBody>
-      </p:sp>
-      <p:sp>
-        <p:nvSpPr>
-          <p:cNvPr id="19" name="FooterBand"/>
-          <p:cNvSpPr/>
-          <p:nvPr/>
-        </p:nvSpPr>
-        <p:spPr>
-          <a:xfrm>
-            <a:off x="274320" y="5879592"/>
-            <a:ext cx="8595360" cy="502920"/>
-          </a:xfrm>
-          <a:prstGeom prst="rect">
-            <a:avLst/>
-          </a:prstGeom>
-          <a:solidFill>
-            <a:srgbClr val="8E6F3E"/>
-          </a:solidFill>
-          <a:ln>
-            <a:noFill/>
-          </a:ln>
-          <a:effectLst/>
-        </p:spPr>
-        <p:style>
-          <a:lnRef idx="1">
-            <a:schemeClr val="accent1"/>
-          </a:lnRef>
-          <a:fillRef idx="3">
-            <a:schemeClr val="accent1"/>
-          </a:fillRef>
-          <a:effectRef idx="2">
-            <a:schemeClr val="accent1"/>
-          </a:effectRef>
-          <a:fontRef idx="minor">
-            <a:schemeClr val="lt1"/>
-          </a:fontRef>
-        </p:style>
-        <p:txBody>
-          <a:bodyPr rtlCol="0" anchor="ctr" wrap="square"/>
-          <a:lstStyle/>
-          <a:p>
-            <a:pPr algn="ctr"/>
-          </a:p>
-        </p:txBody>
-      </p:sp>
-      <p:sp>
-        <p:nvSpPr>
-          <p:cNvPr id="20" name="FooterBandText"/>
-          <p:cNvSpPr txBox="1"/>
-          <p:nvPr/>
-        </p:nvSpPr>
-        <p:spPr>
-          <a:xfrm>
-            <a:off x="384048" y="5897880"/>
-            <a:ext cx="8375904" cy="457200"/>
-          </a:xfrm>
-          <a:prstGeom prst="rect">
-            <a:avLst/>
-          </a:prstGeom>
-          <a:noFill/>
-        </p:spPr>
-        <p:txBody>
-          <a:bodyPr wrap="square">
-            <a:spAutoFit/>
-          </a:bodyPr>
-          <a:lstStyle/>
-          <a:p>
-            <a:pPr algn="ctr">
-              <a:spcAft>
-                <a:spcPts val="400"/>
-              </a:spcAft>
-            </a:pPr>
-            <a:r>
-              <a:rPr sz="2000" b="1">
-                <a:solidFill>
-                  <a:srgbClr val="FFFFFF"/>
-                </a:solidFill>
-                <a:latin typeface="Calibri"/>
-              </a:rPr>
-              <a:t>The same method as Tuesday: different models, same discipline</a:t>
-            </a:r>
-          </a:p>
-        </p:txBody>
-      </p:sp>
     </p:spTree>
   </p:cSld>
   <p:clrMapOvr>

</xml_diff>

<commit_message>
deck 3-2 author review Band P2: title prominence, shadow removal, ER cardinality notation, s11 primary key, direct-SQL path on layer stack, overclaim rewordings s14/s19/s23/s25, diagram enlargements s16/s22, s18/s19 label collision fix
</commit_message>
<xml_diff>
--- a/course/lectures/act-3-software-in-the-world/03-data-management/3-2-Data-Management.pptx
+++ b/course/lectures/act-3-software-in-the-world/03-data-management/3-2-Data-Management.pptx
@@ -1770,6 +1770,12 @@
               <a:t>One caution forward: every copied fact is a new invariant ("copies agree") that someone must now enforce — the same shape as our overlap invariant, and the same question: WHERE does enforcement live?</a:t>
             </a:r>
           </a:p>
+          <a:p/>
+          <a:p>
+            <a:r>
+              <a:t>Moved from slide (bottom panel): The reservations page shows a room name beside every booking Join on every read, or copy and own the copies' staleness. The read/write mix settles it, not a doctrine. The workload decides: join on every read, or copy and own the copies' staleness. The read/write mix settles it, not a doctrine.</a:t>
+            </a:r>
+          </a:p>
         </p:txBody>
       </p:sp>
       <p:sp>
@@ -2148,6 +2154,12 @@
               <a:t>Ask: where in this stack did our overlap invariant go? (Nowhere yet — it is still only in our heads and in one WHERE clause. Keep that discomfort alive until slide 23.)</a:t>
             </a:r>
           </a:p>
+          <a:p/>
+          <a:p>
+            <a:r>
+              <a:t>Moved from slide (right panel): An ORM maps application operations to database queries The database still determines how those queries execute. The added right-hand path matters: an application may issue SQL directly, beside or instead of the ORM — not every query must pass through the ORM layer. Both paths meet at SQL; everything below is identical.</a:t>
+            </a:r>
+          </a:p>
         </p:txBody>
       </p:sp>
       <p:sp>
@@ -2324,6 +2336,12 @@
               <a:t>Ask which columns our overlap query wants indexed (room_id, then time). Then the other edge: every insert now maintains the index too — a write-heavy telemetry table (slide 8's system B) might rightly carry fewer indexes. Design decision, access pattern in, index out.</a:t>
             </a:r>
           </a:p>
+          <a:p/>
+          <a:p>
+            <a:r>
+              <a:t>Moved from slide (bottom panel): Same query text; the index changed the plan An index is bought, not free: faster reads, paid for on every write, chosen per access pattern.</a:t>
+            </a:r>
+          </a:p>
         </p:txBody>
       </p:sp>
       <p:sp>
@@ -2418,6 +2436,12 @@
               <a:t>Transition: everything so far assumed one request at a time. Drop that assumption.</a:t>
             </a:r>
           </a:p>
+          <a:p/>
+          <a:p>
+            <a:r>
+              <a:t>Claim softened (author review): batching strategies vary — a JOIN is one query, but prefetching may issue two or a few batched queries; the point is O(1)-ish, not literally one round trip. And functional tests MAY not reveal access-pattern defects; performance tests and query-count assertions can.</a:t>
+            </a:r>
+          </a:p>
         </p:txBody>
       </p:sp>
       <p:sp>
@@ -2724,6 +2748,12 @@
               <a:t>Consistency concerns the invariants the database actually knows about: transactions preserve the specified integrity constraints. Application invariants never represented in the database require additional engineering — a constraint, an isolation contract, or a locking discipline (the three-fixes slide). Isolation is the letter with a dial, and the next two slides turn it.</a:t>
             </a:r>
           </a:p>
+          <a:p/>
+          <a:p>
+            <a:r>
+              <a:t>Durability qualification (moved off slide): what "survives crashes" means depends on the database's configuration and failure model — fsync policy, replication acknowledgment level, and what failure classes (process, node, disk, site) the deployment is engineered to absorb.</a:t>
+            </a:r>
+          </a:p>
         </p:txBody>
       </p:sp>
       <p:sp>
@@ -2817,6 +2847,12 @@
               <a:t>Point at the ✗: our double-booking history sits INSIDE what weaker levels permit and OUTSIDE the serializable core. Excluding it is exactly what we will pay for.</a:t>
             </a:r>
           </a:p>
+          <a:p/>
+          <a:p>
+            <a:r>
+              <a:t>Moved from slide (bottom panel): Act II's move again: correctness = every permitted history preserves the invariant With the check and the insert inside one transaction, one request must appear to run second; its check then sees the other's row.</a:t>
+            </a:r>
+          </a:p>
         </p:txBody>
       </p:sp>
       <p:sp>
@@ -2905,6 +2941,12 @@
               <a:t>So "we use transactions" does not settle slide 19. Either the level excludes the history (bottom row, with retry costs), or the invariant needs a different home — next slide.</a:t>
             </a:r>
           </a:p>
+          <a:p/>
+          <a:p>
+            <a:r>
+              <a:t>Wording correction (author review): serializable does NOT mean every pair of concurrent transactions aborts. The guarantee is that the conflicting execution cannot commit unchanged; the engine may abort one transaction, which the application catches and retries.</a:t>
+            </a:r>
+          </a:p>
         </p:txBody>
       </p:sp>
       <p:sp>
@@ -3145,6 +3187,12 @@
               <a:t>Handoff: "how much does it cost under OUR workload?" is a measurement question — Performance &amp; Reliability, two lectures from now.</a:t>
             </a:r>
           </a:p>
+          <a:p/>
+          <a:p>
+            <a:r>
+              <a:t>Moved from slide (bottom panel): Pay for exactly the histories you must exclude Telemetry may tolerate weaker coordination guarantees; reservations require stronger protection against conflicting writes. Measuring that price is the next unit: Performance &amp; Reliability. Measuring that price is the next unit: Performance &amp; Reliability.</a:t>
+            </a:r>
+          </a:p>
         </p:txBody>
       </p:sp>
       <p:sp>
@@ -3947,6 +3995,12 @@
               <a:t>SQLite vs PostgreSQL is the cleanest proof that database selection is multidimensional: the same data model and query language at two very different deployment and operational points. 'Relational vs NoSQL' is one axis of several, not the whole decision.</a:t>
             </a:r>
           </a:p>
+          <a:p/>
+          <a:p>
+            <a:r>
+              <a:t>Moved off slide (author review): the SQLite-vs-PostgreSQL deployment contrast now lives on the dedicated storage-mechanism slide (4B). Same data model, different deployment; selection is multidimensional.</a:t>
+            </a:r>
+          </a:p>
         </p:txBody>
       </p:sp>
       <p:sp>
@@ -4208,6 +4262,12 @@
           <a:p>
             <a:r>
               <a:t>Ask: could we model this as ROOM embedding a list of reservations? Yes — that is the document shape from slide 5; the invariant then lives inside one document, which will matter later. The relational shape makes the reservation a first-class row.</a:t>
+            </a:r>
+          </a:p>
+          <a:p/>
+          <a:p>
+            <a:r>
+              <a:t>The relationship lines carry cardinality notation (1 : N, N : 1), not direction: these are ER relationships, not data flow. Read them aloud as "one user holds many reservations; many reservations belong to one room."</a:t>
             </a:r>
           </a:p>
         </p:txBody>
@@ -11419,7 +11479,7 @@
               </a:spcAft>
             </a:pPr>
             <a:r>
-              <a:rPr sz="3200" b="0">
+              <a:rPr sz="4000" b="1">
                 <a:solidFill>
                   <a:srgbClr val="2D2D2D"/>
                 </a:solidFill>
@@ -11809,7 +11869,7 @@
                 </a:solidFill>
                 <a:latin typeface="Calibri"/>
               </a:rPr>
-              <a:t>One authoritative copy</a:t>
+              <a:t>Coherent shared state</a:t>
             </a:r>
           </a:p>
           <a:p>
@@ -12293,7 +12353,7 @@
                 </a:solidFill>
                 <a:latin typeface="Calibri"/>
               </a:rPr>
-              <a:t>1 user → N reservations</a:t>
+              <a:t>1 : N</a:t>
             </a:r>
           </a:p>
         </p:txBody>
@@ -12332,7 +12392,7 @@
                 </a:solidFill>
                 <a:latin typeface="Calibri"/>
               </a:rPr>
-              <a:t>N reservations ← 1 room</a:t>
+              <a:t>N : 1</a:t>
             </a:r>
           </a:p>
         </p:txBody>
@@ -12355,7 +12415,8 @@
             <a:solidFill>
               <a:srgbClr val="8E6F3E"/>
             </a:solidFill>
-            <a:tailEnd type="triangle" w="med" len="med"/>
+            <a:headEnd type="none"/>
+            <a:tailEnd type="none"/>
           </a:ln>
         </p:spPr>
         <p:style>
@@ -12391,7 +12452,8 @@
             <a:solidFill>
               <a:srgbClr val="8E6F3E"/>
             </a:solidFill>
-            <a:headEnd type="triangle" w="med" len="med"/>
+            <a:headEnd type="none"/>
+            <a:tailEnd type="none"/>
           </a:ln>
         </p:spPr>
         <p:style>
@@ -12896,7 +12958,7 @@
                 </a:solidFill>
                 <a:latin typeface="Calibri"/>
               </a:rPr>
-              <a:t>Entities supply the vocabulary (room_id, starts_at, ends_at, status); nothing here enforces it</a:t>
+              <a:t>The entities make the invariant expressible; they do not enforce it.</a:t>
             </a:r>
           </a:p>
         </p:txBody>
@@ -13056,6 +13118,22 @@
                 </a:solidFill>
                 <a:latin typeface="Consolas"/>
               </a:rPr>
+              <a:t>  id        INT PRIMARY KEY,</a:t>
+            </a:r>
+          </a:p>
+          <a:p>
+            <a:pPr algn="l">
+              <a:spcAft>
+                <a:spcPts val="100"/>
+              </a:spcAft>
+            </a:pPr>
+            <a:r>
+              <a:rPr sz="2000" b="0">
+                <a:solidFill>
+                  <a:srgbClr val="2D2D2D"/>
+                </a:solidFill>
+                <a:latin typeface="Consolas"/>
+              </a:rPr>
               <a:t>  room_id  INT REFERENCES rooms,</a:t>
             </a:r>
           </a:p>
@@ -13735,7 +13813,7 @@
         <p:spPr>
           <a:xfrm>
             <a:off x="411480" y="3566160"/>
-            <a:ext cx="8321040" cy="1508760"/>
+            <a:ext cx="8321040" cy="731520"/>
           </a:xfrm>
           <a:prstGeom prst="rect">
             <a:avLst/>
@@ -13779,7 +13857,7 @@
         <p:spPr>
           <a:xfrm>
             <a:off x="557784" y="3639312"/>
-            <a:ext cx="8046720" cy="1371600"/>
+            <a:ext cx="8046720" cy="594360"/>
           </a:xfrm>
           <a:prstGeom prst="rect">
             <a:avLst/>
@@ -13804,23 +13882,7 @@
                 </a:solidFill>
                 <a:latin typeface="Calibri"/>
               </a:rPr>
-              <a:t>The reservations page shows a room name beside every booking</a:t>
-            </a:r>
-          </a:p>
-          <a:p>
-            <a:pPr algn="l">
-              <a:spcAft>
-                <a:spcPts val="400"/>
-              </a:spcAft>
-            </a:pPr>
-            <a:r>
-              <a:rPr sz="2000" b="0">
-                <a:solidFill>
-                  <a:srgbClr val="555960"/>
-                </a:solidFill>
-                <a:latin typeface="Calibri"/>
-              </a:rPr>
-              <a:t>Join on every read, or copy and own the copies' staleness. The read/write mix settles it, not a doctrine.</a:t>
+              <a:t>Read cost ↔ Update consistency</a:t>
             </a:r>
           </a:p>
         </p:txBody>
@@ -14858,7 +14920,7 @@
                 </a:solidFill>
                 <a:latin typeface="Calibri"/>
               </a:rPr>
-              <a:t>This predicate is the invariant in query form. It returns when requests overlap.</a:t>
+              <a:t>This predicate identifies conflicting reservations. Enforcement requires an additional mechanism.</a:t>
             </a:r>
           </a:p>
         </p:txBody>
@@ -15441,8 +15503,8 @@
         </p:nvSpPr>
         <p:spPr>
           <a:xfrm>
-            <a:off x="914400" y="914400"/>
-            <a:ext cx="4206240" cy="640080"/>
+            <a:off x="1097280" y="914400"/>
+            <a:ext cx="5120640" cy="731520"/>
           </a:xfrm>
           <a:prstGeom prst="rect">
             <a:avLst/>
@@ -15498,8 +15560,8 @@
         </p:nvSpPr>
         <p:spPr>
           <a:xfrm>
-            <a:off x="2834640" y="1572768"/>
-            <a:ext cx="365760" cy="192024"/>
+            <a:off x="3474720" y="1645920"/>
+            <a:ext cx="365760" cy="228600"/>
           </a:xfrm>
           <a:prstGeom prst="downArrow">
             <a:avLst/>
@@ -15542,8 +15604,8 @@
         </p:nvSpPr>
         <p:spPr>
           <a:xfrm>
-            <a:off x="914400" y="1783080"/>
-            <a:ext cx="4206240" cy="640080"/>
+            <a:off x="1097280" y="1874520"/>
+            <a:ext cx="5120640" cy="731520"/>
           </a:xfrm>
           <a:prstGeom prst="rect">
             <a:avLst/>
@@ -15599,8 +15661,8 @@
         </p:nvSpPr>
         <p:spPr>
           <a:xfrm>
-            <a:off x="2834640" y="2441448"/>
-            <a:ext cx="365760" cy="192024"/>
+            <a:off x="3474720" y="2606040"/>
+            <a:ext cx="365760" cy="228600"/>
           </a:xfrm>
           <a:prstGeom prst="downArrow">
             <a:avLst/>
@@ -15643,8 +15705,8 @@
         </p:nvSpPr>
         <p:spPr>
           <a:xfrm>
-            <a:off x="914400" y="2651760"/>
-            <a:ext cx="4206240" cy="640080"/>
+            <a:off x="1097280" y="2834640"/>
+            <a:ext cx="5120640" cy="731520"/>
           </a:xfrm>
           <a:prstGeom prst="rect">
             <a:avLst/>
@@ -15700,8 +15762,8 @@
         </p:nvSpPr>
         <p:spPr>
           <a:xfrm>
-            <a:off x="2834640" y="3310128"/>
-            <a:ext cx="365760" cy="192024"/>
+            <a:off x="3474720" y="3566160"/>
+            <a:ext cx="365760" cy="228600"/>
           </a:xfrm>
           <a:prstGeom prst="downArrow">
             <a:avLst/>
@@ -15744,8 +15806,8 @@
         </p:nvSpPr>
         <p:spPr>
           <a:xfrm>
-            <a:off x="914400" y="3520440"/>
-            <a:ext cx="4206240" cy="640080"/>
+            <a:off x="1097280" y="3794760"/>
+            <a:ext cx="5120640" cy="731520"/>
           </a:xfrm>
           <a:prstGeom prst="rect">
             <a:avLst/>
@@ -15801,8 +15863,8 @@
         </p:nvSpPr>
         <p:spPr>
           <a:xfrm>
-            <a:off x="2834640" y="4178808"/>
-            <a:ext cx="365760" cy="192024"/>
+            <a:off x="3474720" y="4526280"/>
+            <a:ext cx="365760" cy="228600"/>
           </a:xfrm>
           <a:prstGeom prst="downArrow">
             <a:avLst/>
@@ -15845,8 +15907,8 @@
         </p:nvSpPr>
         <p:spPr>
           <a:xfrm>
-            <a:off x="914400" y="4389120"/>
-            <a:ext cx="4206240" cy="640080"/>
+            <a:off x="1097280" y="4754880"/>
+            <a:ext cx="5120640" cy="731520"/>
           </a:xfrm>
           <a:prstGeom prst="rect">
             <a:avLst/>
@@ -15894,22 +15956,92 @@
           </a:p>
         </p:txBody>
       </p:sp>
-      <p:sp>
-        <p:nvSpPr>
-          <p:cNvPr id="12" name="Card"/>
+      <p:cxnSp>
+        <p:nvCxnSpPr>
+          <p:cNvPr id="12" name="DirectSqlH"/>
+          <p:cNvCxnSpPr/>
+          <p:nvPr/>
+        </p:nvCxnSpPr>
+        <p:spPr>
+          <a:xfrm>
+            <a:off x="6217920" y="1280160"/>
+            <a:ext cx="731520" cy="0"/>
+          </a:xfrm>
+          <a:prstGeom prst="line">
+            <a:avLst/>
+          </a:prstGeom>
+          <a:ln w="25400">
+            <a:solidFill>
+              <a:srgbClr val="8E6F3E"/>
+            </a:solidFill>
+          </a:ln>
+        </p:spPr>
+        <p:style>
+          <a:lnRef idx="2">
+            <a:schemeClr val="accent1"/>
+          </a:lnRef>
+          <a:fillRef idx="0">
+            <a:schemeClr val="accent1"/>
+          </a:fillRef>
+          <a:effectRef idx="1">
+            <a:schemeClr val="accent1"/>
+          </a:effectRef>
+          <a:fontRef idx="minor">
+            <a:schemeClr val="tx1"/>
+          </a:fontRef>
+        </p:style>
+      </p:cxnSp>
+      <p:cxnSp>
+        <p:nvCxnSpPr>
+          <p:cNvPr id="13" name="DirectSqlV"/>
+          <p:cNvCxnSpPr/>
+          <p:nvPr/>
+        </p:nvCxnSpPr>
+        <p:spPr>
+          <a:xfrm>
+            <a:off x="6949440" y="1280160"/>
+            <a:ext cx="0" cy="1920240"/>
+          </a:xfrm>
+          <a:prstGeom prst="line">
+            <a:avLst/>
+          </a:prstGeom>
+          <a:ln w="25400">
+            <a:solidFill>
+              <a:srgbClr val="8E6F3E"/>
+            </a:solidFill>
+          </a:ln>
+        </p:spPr>
+        <p:style>
+          <a:lnRef idx="2">
+            <a:schemeClr val="accent1"/>
+          </a:lnRef>
+          <a:fillRef idx="0">
+            <a:schemeClr val="accent1"/>
+          </a:fillRef>
+          <a:effectRef idx="1">
+            <a:schemeClr val="accent1"/>
+          </a:effectRef>
+          <a:fontRef idx="minor">
+            <a:schemeClr val="tx1"/>
+          </a:fontRef>
+        </p:style>
+      </p:cxnSp>
+      <p:sp>
+        <p:nvSpPr>
+          <p:cNvPr id="14" name="Arrow"/>
           <p:cNvSpPr/>
           <p:nvPr/>
         </p:nvSpPr>
         <p:spPr>
           <a:xfrm>
-            <a:off x="5486400" y="1783080"/>
-            <a:ext cx="3246120" cy="2377440"/>
-          </a:xfrm>
-          <a:prstGeom prst="rect">
+            <a:off x="6217920" y="3063240"/>
+            <a:ext cx="731520" cy="274320"/>
+          </a:xfrm>
+          <a:prstGeom prst="leftArrow">
             <a:avLst/>
           </a:prstGeom>
           <a:solidFill>
-            <a:srgbClr val="F5F1E8"/>
+            <a:srgbClr val="8E6F3E"/>
           </a:solidFill>
           <a:ln>
             <a:noFill/>
@@ -15940,14 +16072,14 @@
       </p:sp>
       <p:sp>
         <p:nvSpPr>
-          <p:cNvPr id="13" name="CardBody"/>
+          <p:cNvPr id="15" name="DirectSqlLabel"/>
           <p:cNvSpPr txBox="1"/>
           <p:nvPr/>
         </p:nvSpPr>
         <p:spPr>
           <a:xfrm>
-            <a:off x="5632704" y="1874519"/>
-            <a:ext cx="2953512" cy="2194560"/>
+            <a:off x="7040880" y="1965960"/>
+            <a:ext cx="1645920" cy="731520"/>
           </a:xfrm>
           <a:prstGeom prst="rect">
             <a:avLst/>
@@ -15960,27 +16092,6 @@
           </a:bodyPr>
           <a:lstStyle/>
           <a:p>
-            <a:pPr algn="l">
-              <a:spcAft>
-                <a:spcPts val="600"/>
-              </a:spcAft>
-            </a:pPr>
-            <a:r>
-              <a:rPr sz="2000" b="1">
-                <a:solidFill>
-                  <a:srgbClr val="5C4826"/>
-                </a:solidFill>
-                <a:latin typeface="Calibri"/>
-              </a:rPr>
-              <a:t>An ORM maps application operations to database queries</a:t>
-            </a:r>
-          </a:p>
-          <a:p>
-            <a:pPr algn="l">
-              <a:spcAft>
-                <a:spcPts val="600"/>
-              </a:spcAft>
-            </a:pPr>
             <a:r>
               <a:rPr sz="2000" b="0">
                 <a:solidFill>
@@ -15988,7 +16099,7 @@
                 </a:solidFill>
                 <a:latin typeface="Calibri"/>
               </a:rPr>
-              <a:t>The database still determines how those queries execute.</a:t>
+              <a:t>direct SQL, no ORM</a:t>
             </a:r>
           </a:p>
         </p:txBody>
@@ -17130,7 +17241,7 @@
         </p:nvSpPr>
         <p:spPr>
           <a:xfrm>
-            <a:off x="411480" y="960120"/>
+            <a:off x="411480" y="1188720"/>
             <a:ext cx="4069080" cy="2560320"/>
           </a:xfrm>
           <a:prstGeom prst="rect">
@@ -17174,7 +17285,7 @@
         </p:nvSpPr>
         <p:spPr>
           <a:xfrm>
-            <a:off x="557784" y="1051560"/>
+            <a:off x="557784" y="1280160"/>
             <a:ext cx="3776472" cy="2377440"/>
           </a:xfrm>
           <a:prstGeom prst="rect">
@@ -17245,7 +17356,7 @@
         </p:nvSpPr>
         <p:spPr>
           <a:xfrm>
-            <a:off x="4663440" y="960120"/>
+            <a:off x="4663440" y="1188720"/>
             <a:ext cx="4069080" cy="2560320"/>
           </a:xfrm>
           <a:prstGeom prst="rect">
@@ -17289,7 +17400,7 @@
         </p:nvSpPr>
         <p:spPr>
           <a:xfrm>
-            <a:off x="4809744" y="1051560"/>
+            <a:off x="4809744" y="1280160"/>
             <a:ext cx="3776472" cy="2377440"/>
           </a:xfrm>
           <a:prstGeom prst="rect">
@@ -17376,8 +17487,8 @@
         </p:nvSpPr>
         <p:spPr>
           <a:xfrm>
-            <a:off x="411480" y="3749039"/>
-            <a:ext cx="8321040" cy="1371600"/>
+            <a:off x="411480" y="3977639"/>
+            <a:ext cx="8321040" cy="731520"/>
           </a:xfrm>
           <a:prstGeom prst="rect">
             <a:avLst/>
@@ -17420,8 +17531,8 @@
         </p:nvSpPr>
         <p:spPr>
           <a:xfrm>
-            <a:off x="557784" y="3822191"/>
-            <a:ext cx="8046720" cy="1234440"/>
+            <a:off x="557784" y="4050791"/>
+            <a:ext cx="8046720" cy="594360"/>
           </a:xfrm>
           <a:prstGeom prst="rect">
             <a:avLst/>
@@ -17446,23 +17557,7 @@
                 </a:solidFill>
                 <a:latin typeface="Calibri"/>
               </a:rPr>
-              <a:t>Same query text; the index changed the plan</a:t>
-            </a:r>
-          </a:p>
-          <a:p>
-            <a:pPr algn="l">
-              <a:spcAft>
-                <a:spcPts val="400"/>
-              </a:spcAft>
-            </a:pPr>
-            <a:r>
-              <a:rPr sz="2000" b="0">
-                <a:solidFill>
-                  <a:srgbClr val="555960"/>
-                </a:solidFill>
-                <a:latin typeface="Calibri"/>
-              </a:rPr>
-              <a:t>An index is bought, not free: faster reads, paid for on every write, chosen per access pattern.</a:t>
+              <a:t>Indexes trade write and storage costs for faster selected reads</a:t>
             </a:r>
           </a:p>
         </p:txBody>
@@ -17475,7 +17570,7 @@
         </p:nvSpPr>
         <p:spPr>
           <a:xfrm>
-            <a:off x="411480" y="731520"/>
+            <a:off x="411480" y="749808"/>
             <a:ext cx="8321040" cy="365760"/>
           </a:xfrm>
           <a:prstGeom prst="rect">
@@ -17575,7 +17670,7 @@
           <a:fillRef idx="3">
             <a:schemeClr val="accent1"/>
           </a:fillRef>
-          <a:effectRef idx="2">
+          <a:effectRef idx="0">
             <a:schemeClr val="accent1"/>
           </a:effectRef>
           <a:fontRef idx="minor">
@@ -17613,7 +17708,7 @@
           <a:lstStyle/>
           <a:p>
             <a:r>
-              <a:rPr sz="2000" b="1">
+              <a:rPr sz="2200" b="1">
                 <a:solidFill>
                   <a:srgbClr val="8E6F3E"/>
                 </a:solidFill>
@@ -17687,7 +17782,7 @@
           <a:fillRef idx="3">
             <a:schemeClr val="accent1"/>
           </a:fillRef>
-          <a:effectRef idx="2">
+          <a:effectRef idx="0">
             <a:schemeClr val="accent1"/>
           </a:effectRef>
           <a:fontRef idx="minor">
@@ -17725,7 +17820,7 @@
           <a:lstStyle/>
           <a:p>
             <a:r>
-              <a:rPr sz="2000" b="1">
+              <a:rPr sz="2200" b="1">
                 <a:solidFill>
                   <a:srgbClr val="8E6F3E"/>
                 </a:solidFill>
@@ -17799,7 +17894,7 @@
           <a:fillRef idx="3">
             <a:schemeClr val="accent1"/>
           </a:fillRef>
-          <a:effectRef idx="2">
+          <a:effectRef idx="0">
             <a:schemeClr val="accent1"/>
           </a:effectRef>
           <a:fontRef idx="minor">
@@ -17837,7 +17932,7 @@
           <a:lstStyle/>
           <a:p>
             <a:r>
-              <a:rPr sz="2000" b="1">
+              <a:rPr sz="2200" b="1">
                 <a:solidFill>
                   <a:srgbClr val="8E6F3E"/>
                 </a:solidFill>
@@ -17911,7 +18006,7 @@
           <a:fillRef idx="3">
             <a:schemeClr val="accent1"/>
           </a:fillRef>
-          <a:effectRef idx="2">
+          <a:effectRef idx="0">
             <a:schemeClr val="accent1"/>
           </a:effectRef>
           <a:fontRef idx="minor">
@@ -17949,7 +18044,7 @@
           <a:lstStyle/>
           <a:p>
             <a:r>
-              <a:rPr sz="2000" b="1">
+              <a:rPr sz="2200" b="1">
                 <a:solidFill>
                   <a:srgbClr val="8E6F3E"/>
                 </a:solidFill>
@@ -18023,7 +18118,7 @@
           <a:fillRef idx="3">
             <a:schemeClr val="accent1"/>
           </a:fillRef>
-          <a:effectRef idx="2">
+          <a:effectRef idx="0">
             <a:schemeClr val="accent1"/>
           </a:effectRef>
           <a:fontRef idx="minor">
@@ -18061,7 +18156,7 @@
           <a:lstStyle/>
           <a:p>
             <a:r>
-              <a:rPr sz="2000" b="1">
+              <a:rPr sz="2200" b="1">
                 <a:solidFill>
                   <a:srgbClr val="8E6F3E"/>
                 </a:solidFill>
@@ -18376,7 +18471,7 @@
                 </a:solidFill>
                 <a:latin typeface="Calibri"/>
               </a:rPr>
-              <a:t>One JOIN (or prefetch) → one round trip</a:t>
+              <a:t>JOIN or prefetch: one or a few batched queries</a:t>
             </a:r>
           </a:p>
         </p:txBody>
@@ -18574,7 +18669,7 @@
                 </a:solidFill>
                 <a:latin typeface="Calibri"/>
               </a:rPr>
-              <a:t>Tests for correctness will not catch an access-pattern defect</a:t>
+              <a:t>Functional correctness tests may not reveal inefficient access patterns</a:t>
             </a:r>
           </a:p>
         </p:txBody>
@@ -19973,7 +20068,7 @@
         <p:spPr>
           <a:xfrm>
             <a:off x="640080" y="914400"/>
-            <a:ext cx="7863840" cy="3154680"/>
+            <a:ext cx="7863840" cy="3840480"/>
           </a:xfrm>
           <a:prstGeom prst="rect">
             <a:avLst/>
@@ -20018,8 +20113,8 @@
         </p:nvSpPr>
         <p:spPr>
           <a:xfrm>
-            <a:off x="1188720" y="1627632"/>
-            <a:ext cx="6766560" cy="2212848"/>
+            <a:off x="1188720" y="1737360"/>
+            <a:ext cx="6766560" cy="2651760"/>
           </a:xfrm>
           <a:prstGeom prst="rect">
             <a:avLst/>
@@ -20064,8 +20159,8 @@
         </p:nvSpPr>
         <p:spPr>
           <a:xfrm>
-            <a:off x="1783080" y="2487168"/>
-            <a:ext cx="3749039" cy="1078992"/>
+            <a:off x="1783080" y="2834640"/>
+            <a:ext cx="3749039" cy="1280160"/>
           </a:xfrm>
           <a:prstGeom prst="rect">
             <a:avLst/>
@@ -20163,7 +20258,7 @@
         </p:nvSpPr>
         <p:spPr>
           <a:xfrm>
-            <a:off x="1371600" y="1700784"/>
+            <a:off x="1371600" y="1810512"/>
             <a:ext cx="6035040" cy="365760"/>
           </a:xfrm>
           <a:prstGeom prst="rect">
@@ -20197,7 +20292,7 @@
         </p:nvSpPr>
         <p:spPr>
           <a:xfrm>
-            <a:off x="5760720" y="2651760"/>
+            <a:off x="5760720" y="3108960"/>
             <a:ext cx="2103120" cy="777240"/>
           </a:xfrm>
           <a:prstGeom prst="rect">
@@ -20242,8 +20337,8 @@
         </p:nvSpPr>
         <p:spPr>
           <a:xfrm>
-            <a:off x="411480" y="4251960"/>
-            <a:ext cx="8321040" cy="1417320"/>
+            <a:off x="411480" y="5029200"/>
+            <a:ext cx="8321040" cy="731520"/>
           </a:xfrm>
           <a:prstGeom prst="rect">
             <a:avLst/>
@@ -20286,8 +20381,8 @@
         </p:nvSpPr>
         <p:spPr>
           <a:xfrm>
-            <a:off x="557784" y="4325112"/>
-            <a:ext cx="8046720" cy="1280160"/>
+            <a:off x="557784" y="5102352"/>
+            <a:ext cx="8046720" cy="594360"/>
           </a:xfrm>
           <a:prstGeom prst="rect">
             <a:avLst/>
@@ -20312,23 +20407,7 @@
                 </a:solidFill>
                 <a:latin typeface="Calibri"/>
               </a:rPr>
-              <a:t>Act II's move again: correctness = every permitted history preserves the invariant</a:t>
-            </a:r>
-          </a:p>
-          <a:p>
-            <a:pPr algn="l">
-              <a:spcAft>
-                <a:spcPts val="400"/>
-              </a:spcAft>
-            </a:pPr>
-            <a:r>
-              <a:rPr sz="2000" b="0">
-                <a:solidFill>
-                  <a:srgbClr val="555960"/>
-                </a:solidFill>
-                <a:latin typeface="Calibri"/>
-              </a:rPr>
-              <a:t>With the check and the insert inside one transaction, one request must appear to run second; its check then sees the other's row.</a:t>
+              <a:t>Serializable execution excludes histories equivalent to no valid serial ordering</a:t>
             </a:r>
           </a:p>
         </p:txBody>
@@ -20803,23 +20882,7 @@
                 </a:solidFill>
                 <a:latin typeface="Calibri"/>
               </a:rPr>
-              <a:t>Race excluded: one transaction aborts</a:t>
-            </a:r>
-          </a:p>
-          <a:p>
-            <a:pPr algn="l">
-              <a:spcAft>
-                <a:spcPts val="400"/>
-              </a:spcAft>
-            </a:pPr>
-            <a:r>
-              <a:rPr sz="2000" b="0">
-                <a:solidFill>
-                  <a:srgbClr val="555960"/>
-                </a:solidFill>
-                <a:latin typeface="Calibri"/>
-              </a:rPr>
-              <a:t>Your application must catch the abort and retry</a:t>
+              <a:t>The conflicting execution cannot commit unchanged; an abort and retry may be required</a:t>
             </a:r>
           </a:p>
         </p:txBody>
@@ -22127,7 +22190,7 @@
         <p:spPr>
           <a:xfrm>
             <a:off x="411480" y="3840480"/>
-            <a:ext cx="8321040" cy="1463040"/>
+            <a:ext cx="8321040" cy="1005840"/>
           </a:xfrm>
           <a:prstGeom prst="rect">
             <a:avLst/>
@@ -22171,7 +22234,7 @@
         <p:spPr>
           <a:xfrm>
             <a:off x="557784" y="3913632"/>
-            <a:ext cx="8046720" cy="1325880"/>
+            <a:ext cx="8046720" cy="868680"/>
           </a:xfrm>
           <a:prstGeom prst="rect">
             <a:avLst/>
@@ -22196,7 +22259,7 @@
                 </a:solidFill>
                 <a:latin typeface="Calibri"/>
               </a:rPr>
-              <a:t>Pay for exactly the histories you must exclude</a:t>
+              <a:t>Stronger concurrency guarantees impose coordination costs</a:t>
             </a:r>
           </a:p>
           <a:p>
@@ -22212,7 +22275,7 @@
                 </a:solidFill>
                 <a:latin typeface="Calibri"/>
               </a:rPr>
-              <a:t>Telemetry may tolerate weaker coordination guarantees; reservations require stronger protection against conflicting writes. Measuring that price is the next unit: Performance &amp; Reliability.</a:t>
+              <a:t>Telemetry tolerates weaker guarantees; reservations do not</a:t>
             </a:r>
           </a:p>
         </p:txBody>
@@ -24249,7 +24312,7 @@
                 </a:solidFill>
                 <a:latin typeface="Calibri"/>
               </a:rPr>
-              <a:t>Two copies, two different truths</a:t>
+              <a:t>Two instances, inconsistent reservations</a:t>
             </a:r>
           </a:p>
         </p:txBody>
@@ -26227,45 +26290,6 @@
       </p:sp>
       <p:sp>
         <p:nvSpPr>
-          <p:cNvPr id="18" name="OperationsNote"/>
-          <p:cNvSpPr txBox="1"/>
-          <p:nvPr/>
-        </p:nvSpPr>
-        <p:spPr>
-          <a:xfrm>
-            <a:off x="411480" y="5504688"/>
-            <a:ext cx="8321040" cy="347472"/>
-          </a:xfrm>
-          <a:prstGeom prst="rect">
-            <a:avLst/>
-          </a:prstGeom>
-          <a:noFill/>
-        </p:spPr>
-        <p:txBody>
-          <a:bodyPr wrap="square">
-            <a:spAutoFit/>
-          </a:bodyPr>
-          <a:lstStyle/>
-          <a:p>
-            <a:pPr algn="l">
-              <a:spcAft>
-                <a:spcPts val="400"/>
-              </a:spcAft>
-            </a:pPr>
-            <a:r>
-              <a:rPr sz="2000" b="0">
-                <a:solidFill>
-                  <a:srgbClr val="555960"/>
-                </a:solidFill>
-                <a:latin typeface="Calibri"/>
-              </a:rPr>
-              <a:t>A sixth, Operations (backup, recovery, migration), waits for Operations &amp; SRE</a:t>
-            </a:r>
-          </a:p>
-        </p:txBody>
-      </p:sp>
-      <p:sp>
-        <p:nvSpPr>
           <p:cNvPr id="19" name="FooterBand"/>
           <p:cNvSpPr/>
           <p:nvPr/>
@@ -27549,95 +27573,6 @@
                 <a:latin typeface="Calibri"/>
               </a:rPr>
               <a:t>Some NoSQL systems offer strong consistency and transactions; some relational systems are distributed and horizontally scalable.</a:t>
-            </a:r>
-          </a:p>
-        </p:txBody>
-      </p:sp>
-      <p:sp>
-        <p:nvSpPr>
-          <p:cNvPr id="9" name="Card"/>
-          <p:cNvSpPr/>
-          <p:nvPr/>
-        </p:nvSpPr>
-        <p:spPr>
-          <a:xfrm>
-            <a:off x="411480" y="4983480"/>
-            <a:ext cx="8321040" cy="1005840"/>
-          </a:xfrm>
-          <a:prstGeom prst="rect">
-            <a:avLst/>
-          </a:prstGeom>
-          <a:solidFill>
-            <a:srgbClr val="FCFAF6"/>
-          </a:solidFill>
-          <a:ln>
-            <a:noFill/>
-          </a:ln>
-          <a:effectLst/>
-        </p:spPr>
-        <p:style>
-          <a:lnRef idx="1">
-            <a:schemeClr val="accent1"/>
-          </a:lnRef>
-          <a:fillRef idx="3">
-            <a:schemeClr val="accent1"/>
-          </a:fillRef>
-          <a:effectRef idx="2">
-            <a:schemeClr val="accent1"/>
-          </a:effectRef>
-          <a:fontRef idx="minor">
-            <a:schemeClr val="lt1"/>
-          </a:fontRef>
-        </p:style>
-        <p:txBody>
-          <a:bodyPr rtlCol="0" anchor="ctr"/>
-          <a:lstStyle/>
-          <a:p>
-            <a:pPr algn="ctr"/>
-          </a:p>
-        </p:txBody>
-      </p:sp>
-      <p:sp>
-        <p:nvSpPr>
-          <p:cNvPr id="10" name="MechNote"/>
-          <p:cNvSpPr txBox="1"/>
-          <p:nvPr/>
-        </p:nvSpPr>
-        <p:spPr>
-          <a:xfrm>
-            <a:off x="557784" y="5056632"/>
-            <a:ext cx="8046720" cy="877824"/>
-          </a:xfrm>
-          <a:prstGeom prst="rect">
-            <a:avLst/>
-          </a:prstGeom>
-          <a:noFill/>
-        </p:spPr>
-        <p:txBody>
-          <a:bodyPr wrap="square">
-            <a:spAutoFit/>
-          </a:bodyPr>
-          <a:lstStyle/>
-          <a:p>
-            <a:r>
-              <a:rPr sz="2000" b="1">
-                <a:solidFill>
-                  <a:srgbClr val="8E6F3E"/>
-                </a:solidFill>
-                <a:latin typeface="Calibri"/>
-              </a:rPr>
-              <a:t>SQLite and PostgreSQL are both relational</a:t>
-            </a:r>
-          </a:p>
-          <a:p>
-            <a:r>
-              <a:rPr sz="2000" b="0">
-                <a:solidFill>
-                  <a:srgbClr val="555960"/>
-                </a:solidFill>
-                <a:latin typeface="Calibri"/>
-              </a:rPr>
-              <a:t>Same data model, different deployment: in-process file vs networked server. Selection is multidimensional.</a:t>
             </a:r>
           </a:p>
         </p:txBody>

</xml_diff>